<commit_message>
updated lecture for class 3/4
</commit_message>
<xml_diff>
--- a/lectures/2026_GNET749_Lecture3.pptx
+++ b/lectures/2026_GNET749_Lecture3.pptx
@@ -5,7 +5,7 @@
     <p:sldMasterId id="2147483648" r:id="rId1"/>
   </p:sldMasterIdLst>
   <p:notesMasterIdLst>
-    <p:notesMasterId r:id="rId19"/>
+    <p:notesMasterId r:id="rId18"/>
   </p:notesMasterIdLst>
   <p:sldIdLst>
     <p:sldId id="256" r:id="rId2"/>
@@ -22,9 +22,8 @@
     <p:sldId id="320" r:id="rId13"/>
     <p:sldId id="308" r:id="rId14"/>
     <p:sldId id="321" r:id="rId15"/>
-    <p:sldId id="324" r:id="rId16"/>
-    <p:sldId id="325" r:id="rId17"/>
-    <p:sldId id="303" r:id="rId18"/>
+    <p:sldId id="325" r:id="rId16"/>
+    <p:sldId id="303" r:id="rId17"/>
   </p:sldIdLst>
   <p:sldSz cx="12192000" cy="6858000"/>
   <p:notesSz cx="6858000" cy="9144000"/>
@@ -213,7 +212,7 @@
           <a:p>
             <a:fld id="{CED3B269-BCFD-3E4D-9867-060E5123D2F8}" type="datetimeFigureOut">
               <a:rPr lang="en-US" smtClean="0"/>
-              <a:t>4/21/26</a:t>
+              <a:t>4/22/26</a:t>
             </a:fld>
             <a:endParaRPr lang="en-US"/>
           </a:p>
@@ -708,7 +707,7 @@
           <a:p>
             <a:fld id="{C17BA9DE-A22B-9A47-BD58-93CE3EC6954C}" type="datetimeFigureOut">
               <a:rPr lang="en-US" smtClean="0"/>
-              <a:t>4/21/26</a:t>
+              <a:t>4/22/26</a:t>
             </a:fld>
             <a:endParaRPr lang="en-US"/>
           </a:p>
@@ -906,7 +905,7 @@
           <a:p>
             <a:fld id="{C17BA9DE-A22B-9A47-BD58-93CE3EC6954C}" type="datetimeFigureOut">
               <a:rPr lang="en-US" smtClean="0"/>
-              <a:t>4/21/26</a:t>
+              <a:t>4/22/26</a:t>
             </a:fld>
             <a:endParaRPr lang="en-US"/>
           </a:p>
@@ -1114,7 +1113,7 @@
           <a:p>
             <a:fld id="{C17BA9DE-A22B-9A47-BD58-93CE3EC6954C}" type="datetimeFigureOut">
               <a:rPr lang="en-US" smtClean="0"/>
-              <a:t>4/21/26</a:t>
+              <a:t>4/22/26</a:t>
             </a:fld>
             <a:endParaRPr lang="en-US"/>
           </a:p>
@@ -1312,7 +1311,7 @@
           <a:p>
             <a:fld id="{C17BA9DE-A22B-9A47-BD58-93CE3EC6954C}" type="datetimeFigureOut">
               <a:rPr lang="en-US" smtClean="0"/>
-              <a:t>4/21/26</a:t>
+              <a:t>4/22/26</a:t>
             </a:fld>
             <a:endParaRPr lang="en-US"/>
           </a:p>
@@ -1587,7 +1586,7 @@
           <a:p>
             <a:fld id="{C17BA9DE-A22B-9A47-BD58-93CE3EC6954C}" type="datetimeFigureOut">
               <a:rPr lang="en-US" smtClean="0"/>
-              <a:t>4/21/26</a:t>
+              <a:t>4/22/26</a:t>
             </a:fld>
             <a:endParaRPr lang="en-US"/>
           </a:p>
@@ -1852,7 +1851,7 @@
           <a:p>
             <a:fld id="{C17BA9DE-A22B-9A47-BD58-93CE3EC6954C}" type="datetimeFigureOut">
               <a:rPr lang="en-US" smtClean="0"/>
-              <a:t>4/21/26</a:t>
+              <a:t>4/22/26</a:t>
             </a:fld>
             <a:endParaRPr lang="en-US"/>
           </a:p>
@@ -2264,7 +2263,7 @@
           <a:p>
             <a:fld id="{C17BA9DE-A22B-9A47-BD58-93CE3EC6954C}" type="datetimeFigureOut">
               <a:rPr lang="en-US" smtClean="0"/>
-              <a:t>4/21/26</a:t>
+              <a:t>4/22/26</a:t>
             </a:fld>
             <a:endParaRPr lang="en-US"/>
           </a:p>
@@ -2405,7 +2404,7 @@
           <a:p>
             <a:fld id="{C17BA9DE-A22B-9A47-BD58-93CE3EC6954C}" type="datetimeFigureOut">
               <a:rPr lang="en-US" smtClean="0"/>
-              <a:t>4/21/26</a:t>
+              <a:t>4/22/26</a:t>
             </a:fld>
             <a:endParaRPr lang="en-US"/>
           </a:p>
@@ -2518,7 +2517,7 @@
           <a:p>
             <a:fld id="{C17BA9DE-A22B-9A47-BD58-93CE3EC6954C}" type="datetimeFigureOut">
               <a:rPr lang="en-US" smtClean="0"/>
-              <a:t>4/21/26</a:t>
+              <a:t>4/22/26</a:t>
             </a:fld>
             <a:endParaRPr lang="en-US"/>
           </a:p>
@@ -2829,7 +2828,7 @@
           <a:p>
             <a:fld id="{C17BA9DE-A22B-9A47-BD58-93CE3EC6954C}" type="datetimeFigureOut">
               <a:rPr lang="en-US" smtClean="0"/>
-              <a:t>4/21/26</a:t>
+              <a:t>4/22/26</a:t>
             </a:fld>
             <a:endParaRPr lang="en-US"/>
           </a:p>
@@ -3117,7 +3116,7 @@
           <a:p>
             <a:fld id="{C17BA9DE-A22B-9A47-BD58-93CE3EC6954C}" type="datetimeFigureOut">
               <a:rPr lang="en-US" smtClean="0"/>
-              <a:t>4/21/26</a:t>
+              <a:t>4/22/26</a:t>
             </a:fld>
             <a:endParaRPr lang="en-US"/>
           </a:p>
@@ -3358,7 +3357,7 @@
           <a:p>
             <a:fld id="{C17BA9DE-A22B-9A47-BD58-93CE3EC6954C}" type="datetimeFigureOut">
               <a:rPr lang="en-US" smtClean="0"/>
-              <a:t>4/21/26</a:t>
+              <a:t>4/22/26</a:t>
             </a:fld>
             <a:endParaRPr lang="en-US"/>
           </a:p>
@@ -4029,7 +4028,7 @@
           </a:ln>
           <a:extLst>
             <a:ext uri="{C572A759-6A51-4108-AA02-DFA0A04FC94B}">
-              <ma14:wrappingTextBoxFlag xmlns:ma14="http://schemas.microsoft.com/office/mac/drawingml/2011/main" xmlns:a14="http://schemas.microsoft.com/office/drawing/2010/main" xmlns:m="http://schemas.openxmlformats.org/officeDocument/2006/math" xmlns="" val="1"/>
+              <ma14:wrappingTextBoxFlag xmlns="" xmlns:m="http://schemas.openxmlformats.org/officeDocument/2006/math" xmlns:a14="http://schemas.microsoft.com/office/drawing/2010/main" xmlns:ma14="http://schemas.microsoft.com/office/mac/drawingml/2011/main" val="1"/>
             </a:ext>
           </a:extLst>
         </p:spPr>
@@ -4065,7 +4064,7 @@
           </a:ln>
           <a:extLst>
             <a:ext uri="{C572A759-6A51-4108-AA02-DFA0A04FC94B}">
-              <ma14:wrappingTextBoxFlag xmlns:ma14="http://schemas.microsoft.com/office/mac/drawingml/2011/main" xmlns:a14="http://schemas.microsoft.com/office/drawing/2010/main" xmlns:m="http://schemas.openxmlformats.org/officeDocument/2006/math" xmlns="" val="1"/>
+              <ma14:wrappingTextBoxFlag xmlns="" xmlns:m="http://schemas.openxmlformats.org/officeDocument/2006/math" xmlns:a14="http://schemas.microsoft.com/office/drawing/2010/main" xmlns:ma14="http://schemas.microsoft.com/office/mac/drawingml/2011/main" val="1"/>
             </a:ext>
           </a:extLst>
         </p:spPr>
@@ -4139,7 +4138,7 @@
           </a:ln>
           <a:extLst>
             <a:ext uri="{C572A759-6A51-4108-AA02-DFA0A04FC94B}">
-              <ma14:wrappingTextBoxFlag xmlns:ma14="http://schemas.microsoft.com/office/mac/drawingml/2011/main" xmlns:a14="http://schemas.microsoft.com/office/drawing/2010/main" xmlns:m="http://schemas.openxmlformats.org/officeDocument/2006/math" xmlns="" val="1"/>
+              <ma14:wrappingTextBoxFlag xmlns="" xmlns:m="http://schemas.openxmlformats.org/officeDocument/2006/math" xmlns:a14="http://schemas.microsoft.com/office/drawing/2010/main" xmlns:ma14="http://schemas.microsoft.com/office/mac/drawingml/2011/main" val="1"/>
             </a:ext>
           </a:extLst>
         </p:spPr>
@@ -4229,7 +4228,7 @@
           </a:ln>
           <a:extLst>
             <a:ext uri="{C572A759-6A51-4108-AA02-DFA0A04FC94B}">
-              <ma14:wrappingTextBoxFlag xmlns:ma14="http://schemas.microsoft.com/office/mac/drawingml/2011/main" xmlns:a14="http://schemas.microsoft.com/office/drawing/2010/main" xmlns:m="http://schemas.openxmlformats.org/officeDocument/2006/math" xmlns="" val="1"/>
+              <ma14:wrappingTextBoxFlag xmlns="" xmlns:m="http://schemas.openxmlformats.org/officeDocument/2006/math" xmlns:a14="http://schemas.microsoft.com/office/drawing/2010/main" xmlns:ma14="http://schemas.microsoft.com/office/mac/drawingml/2011/main" val="1"/>
             </a:ext>
           </a:extLst>
         </p:spPr>
@@ -4326,7 +4325,7 @@
             <a:effectLst/>
             <a:extLst>
               <a:ext uri="{C572A759-6A51-4108-AA02-DFA0A04FC94B}">
-                <ma14:wrappingTextBoxFlag xmlns:ma14="http://schemas.microsoft.com/office/mac/drawingml/2011/main" xmlns:a14="http://schemas.microsoft.com/office/drawing/2010/main" xmlns:m="http://schemas.openxmlformats.org/officeDocument/2006/math" xmlns="" val="1"/>
+                <ma14:wrappingTextBoxFlag xmlns="" xmlns:m="http://schemas.openxmlformats.org/officeDocument/2006/math" xmlns:a14="http://schemas.microsoft.com/office/drawing/2010/main" xmlns:ma14="http://schemas.microsoft.com/office/mac/drawingml/2011/main" val="1"/>
               </a:ext>
             </a:extLst>
           </p:spPr>
@@ -5096,131 +5095,6 @@
           <a:chExt cx="0" cy="0"/>
         </a:xfrm>
       </p:grpSpPr>
-      <p:pic>
-        <p:nvPicPr>
-          <p:cNvPr id="2" name="Picture 1">
-            <a:extLst>
-              <a:ext uri="{FF2B5EF4-FFF2-40B4-BE49-F238E27FC236}">
-                <a16:creationId xmlns:a16="http://schemas.microsoft.com/office/drawing/2014/main" id="{7966EE62-CE85-3404-07A6-C94319D05FF9}"/>
-              </a:ext>
-            </a:extLst>
-          </p:cNvPr>
-          <p:cNvPicPr>
-            <a:picLocks noChangeAspect="1"/>
-          </p:cNvPicPr>
-          <p:nvPr/>
-        </p:nvPicPr>
-        <p:blipFill>
-          <a:blip r:embed="rId2"/>
-          <a:stretch>
-            <a:fillRect/>
-          </a:stretch>
-        </p:blipFill>
-        <p:spPr>
-          <a:xfrm>
-            <a:off x="549724" y="718457"/>
-            <a:ext cx="5867768" cy="5421086"/>
-          </a:xfrm>
-          <a:prstGeom prst="rect">
-            <a:avLst/>
-          </a:prstGeom>
-        </p:spPr>
-      </p:pic>
-      <p:sp>
-        <p:nvSpPr>
-          <p:cNvPr id="3" name="TextBox 2">
-            <a:extLst>
-              <a:ext uri="{FF2B5EF4-FFF2-40B4-BE49-F238E27FC236}">
-                <a16:creationId xmlns:a16="http://schemas.microsoft.com/office/drawing/2014/main" id="{E7F5E365-D6F3-5971-16A9-F2EAAACE5CE0}"/>
-              </a:ext>
-            </a:extLst>
-          </p:cNvPr>
-          <p:cNvSpPr txBox="1"/>
-          <p:nvPr/>
-        </p:nvSpPr>
-        <p:spPr>
-          <a:xfrm>
-            <a:off x="4174177" y="190005"/>
-            <a:ext cx="3937745" cy="369332"/>
-          </a:xfrm>
-          <a:prstGeom prst="rect">
-            <a:avLst/>
-          </a:prstGeom>
-          <a:noFill/>
-        </p:spPr>
-        <p:txBody>
-          <a:bodyPr wrap="none" rtlCol="0">
-            <a:spAutoFit/>
-          </a:bodyPr>
-          <a:lstStyle/>
-          <a:p>
-            <a:r>
-              <a:rPr lang="en-US" dirty="0"/>
-              <a:t>R Project templates can help set this up </a:t>
-            </a:r>
-          </a:p>
-        </p:txBody>
-      </p:sp>
-      <p:pic>
-        <p:nvPicPr>
-          <p:cNvPr id="4" name="Picture 3">
-            <a:extLst>
-              <a:ext uri="{FF2B5EF4-FFF2-40B4-BE49-F238E27FC236}">
-                <a16:creationId xmlns:a16="http://schemas.microsoft.com/office/drawing/2014/main" id="{73358556-5CAB-5075-8D93-D0E6E17A1DFE}"/>
-              </a:ext>
-            </a:extLst>
-          </p:cNvPr>
-          <p:cNvPicPr>
-            <a:picLocks noChangeAspect="1"/>
-          </p:cNvPicPr>
-          <p:nvPr/>
-        </p:nvPicPr>
-        <p:blipFill>
-          <a:blip r:embed="rId3"/>
-          <a:stretch>
-            <a:fillRect/>
-          </a:stretch>
-        </p:blipFill>
-        <p:spPr>
-          <a:xfrm>
-            <a:off x="6522226" y="718457"/>
-            <a:ext cx="5444844" cy="5676406"/>
-          </a:xfrm>
-          <a:prstGeom prst="rect">
-            <a:avLst/>
-          </a:prstGeom>
-        </p:spPr>
-      </p:pic>
-    </p:spTree>
-    <p:extLst>
-      <p:ext uri="{BB962C8B-B14F-4D97-AF65-F5344CB8AC3E}">
-        <p14:creationId xmlns:p14="http://schemas.microsoft.com/office/powerpoint/2010/main" val="2399993793"/>
-      </p:ext>
-    </p:extLst>
-  </p:cSld>
-  <p:clrMapOvr>
-    <a:masterClrMapping/>
-  </p:clrMapOvr>
-</p:sld>
-</file>
-
-<file path=ppt/slides/slide16.xml><?xml version="1.0" encoding="utf-8"?>
-<p:sld xmlns:a="http://schemas.openxmlformats.org/drawingml/2006/main" xmlns:r="http://schemas.openxmlformats.org/officeDocument/2006/relationships" xmlns:p="http://schemas.openxmlformats.org/presentationml/2006/main">
-  <p:cSld>
-    <p:spTree>
-      <p:nvGrpSpPr>
-        <p:cNvPr id="1" name=""/>
-        <p:cNvGrpSpPr/>
-        <p:nvPr/>
-      </p:nvGrpSpPr>
-      <p:grpSpPr>
-        <a:xfrm>
-          <a:off x="0" y="0"/>
-          <a:ext cx="0" cy="0"/>
-          <a:chOff x="0" y="0"/>
-          <a:chExt cx="0" cy="0"/>
-        </a:xfrm>
-      </p:grpSpPr>
       <p:sp>
         <p:nvSpPr>
           <p:cNvPr id="2" name="TextBox 1">
@@ -5270,8 +5144,8 @@
         </p:nvSpPr>
         <p:spPr>
           <a:xfrm>
-            <a:off x="2178121" y="1469205"/>
-            <a:ext cx="8065214" cy="2308324"/>
+            <a:off x="2068643" y="1469205"/>
+            <a:ext cx="8174692" cy="2308324"/>
           </a:xfrm>
           <a:prstGeom prst="rect">
             <a:avLst/>
@@ -5447,7 +5321,7 @@
 </p:sld>
 </file>
 
-<file path=ppt/slides/slide17.xml><?xml version="1.0" encoding="utf-8"?>
+<file path=ppt/slides/slide16.xml><?xml version="1.0" encoding="utf-8"?>
 <p:sld xmlns:a="http://schemas.openxmlformats.org/drawingml/2006/main" xmlns:r="http://schemas.openxmlformats.org/officeDocument/2006/relationships" xmlns:p="http://schemas.openxmlformats.org/presentationml/2006/main">
   <p:cSld>
     <p:spTree>
@@ -5914,7 +5788,7 @@
           </a:ln>
           <a:extLst>
             <a:ext uri="{C572A759-6A51-4108-AA02-DFA0A04FC94B}">
-              <ma14:wrappingTextBoxFlag xmlns="" xmlns:m="http://schemas.openxmlformats.org/officeDocument/2006/math" xmlns:a14="http://schemas.microsoft.com/office/drawing/2010/main" xmlns:ma14="http://schemas.microsoft.com/office/mac/drawingml/2011/main" val="1"/>
+              <ma14:wrappingTextBoxFlag xmlns:ma14="http://schemas.microsoft.com/office/mac/drawingml/2011/main" xmlns:a14="http://schemas.microsoft.com/office/drawing/2010/main" xmlns:m="http://schemas.openxmlformats.org/officeDocument/2006/math" xmlns="" val="1"/>
             </a:ext>
           </a:extLst>
         </p:spPr>
@@ -5959,7 +5833,7 @@
           </a:ln>
           <a:extLst>
             <a:ext uri="{C572A759-6A51-4108-AA02-DFA0A04FC94B}">
-              <ma14:wrappingTextBoxFlag xmlns="" xmlns:m="http://schemas.openxmlformats.org/officeDocument/2006/math" xmlns:a14="http://schemas.microsoft.com/office/drawing/2010/main" xmlns:ma14="http://schemas.microsoft.com/office/mac/drawingml/2011/main" val="1"/>
+              <ma14:wrappingTextBoxFlag xmlns:ma14="http://schemas.microsoft.com/office/mac/drawingml/2011/main" xmlns:a14="http://schemas.microsoft.com/office/drawing/2010/main" xmlns:m="http://schemas.openxmlformats.org/officeDocument/2006/math" xmlns="" val="1"/>
             </a:ext>
           </a:extLst>
         </p:spPr>
@@ -6000,7 +5874,7 @@
           </a:ln>
           <a:extLst>
             <a:ext uri="{C572A759-6A51-4108-AA02-DFA0A04FC94B}">
-              <ma14:wrappingTextBoxFlag xmlns="" xmlns:m="http://schemas.openxmlformats.org/officeDocument/2006/math" xmlns:a14="http://schemas.microsoft.com/office/drawing/2010/main" xmlns:ma14="http://schemas.microsoft.com/office/mac/drawingml/2011/main" val="1"/>
+              <ma14:wrappingTextBoxFlag xmlns:ma14="http://schemas.microsoft.com/office/mac/drawingml/2011/main" xmlns:a14="http://schemas.microsoft.com/office/drawing/2010/main" xmlns:m="http://schemas.openxmlformats.org/officeDocument/2006/math" xmlns="" val="1"/>
             </a:ext>
           </a:extLst>
         </p:spPr>
@@ -6060,7 +5934,7 @@
           </a:ln>
           <a:extLst>
             <a:ext uri="{C572A759-6A51-4108-AA02-DFA0A04FC94B}">
-              <ma14:wrappingTextBoxFlag xmlns="" xmlns:m="http://schemas.openxmlformats.org/officeDocument/2006/math" xmlns:a14="http://schemas.microsoft.com/office/drawing/2010/main" xmlns:ma14="http://schemas.microsoft.com/office/mac/drawingml/2011/main" val="1"/>
+              <ma14:wrappingTextBoxFlag xmlns:ma14="http://schemas.microsoft.com/office/mac/drawingml/2011/main" xmlns:a14="http://schemas.microsoft.com/office/drawing/2010/main" xmlns:m="http://schemas.openxmlformats.org/officeDocument/2006/math" xmlns="" val="1"/>
             </a:ext>
           </a:extLst>
         </p:spPr>
@@ -6135,7 +6009,7 @@
           </a:ln>
           <a:extLst>
             <a:ext uri="{C572A759-6A51-4108-AA02-DFA0A04FC94B}">
-              <ma14:wrappingTextBoxFlag xmlns:ma14="http://schemas.microsoft.com/office/mac/drawingml/2011/main" xmlns:a14="http://schemas.microsoft.com/office/drawing/2010/main" xmlns:m="http://schemas.openxmlformats.org/officeDocument/2006/math" xmlns="" val="1"/>
+              <ma14:wrappingTextBoxFlag xmlns="" xmlns:m="http://schemas.openxmlformats.org/officeDocument/2006/math" xmlns:a14="http://schemas.microsoft.com/office/drawing/2010/main" xmlns:ma14="http://schemas.microsoft.com/office/mac/drawingml/2011/main" val="1"/>
             </a:ext>
           </a:extLst>
         </p:spPr>
@@ -6180,7 +6054,7 @@
           </a:ln>
           <a:extLst>
             <a:ext uri="{C572A759-6A51-4108-AA02-DFA0A04FC94B}">
-              <ma14:wrappingTextBoxFlag xmlns:ma14="http://schemas.microsoft.com/office/mac/drawingml/2011/main" xmlns:a14="http://schemas.microsoft.com/office/drawing/2010/main" xmlns:m="http://schemas.openxmlformats.org/officeDocument/2006/math" xmlns="" val="1"/>
+              <ma14:wrappingTextBoxFlag xmlns="" xmlns:m="http://schemas.openxmlformats.org/officeDocument/2006/math" xmlns:a14="http://schemas.microsoft.com/office/drawing/2010/main" xmlns:ma14="http://schemas.microsoft.com/office/mac/drawingml/2011/main" val="1"/>
             </a:ext>
           </a:extLst>
         </p:spPr>
@@ -6367,7 +6241,7 @@
           </a:ln>
           <a:extLst>
             <a:ext uri="{C572A759-6A51-4108-AA02-DFA0A04FC94B}">
-              <ma14:wrappingTextBoxFlag xmlns:ma14="http://schemas.microsoft.com/office/mac/drawingml/2011/main" xmlns:a14="http://schemas.microsoft.com/office/drawing/2010/main" xmlns:m="http://schemas.openxmlformats.org/officeDocument/2006/math" xmlns="" val="1"/>
+              <ma14:wrappingTextBoxFlag xmlns="" xmlns:m="http://schemas.openxmlformats.org/officeDocument/2006/math" xmlns:a14="http://schemas.microsoft.com/office/drawing/2010/main" xmlns:ma14="http://schemas.microsoft.com/office/mac/drawingml/2011/main" val="1"/>
             </a:ext>
           </a:extLst>
         </p:spPr>
@@ -6408,7 +6282,7 @@
           </a:ln>
           <a:extLst>
             <a:ext uri="{C572A759-6A51-4108-AA02-DFA0A04FC94B}">
-              <ma14:wrappingTextBoxFlag xmlns:ma14="http://schemas.microsoft.com/office/mac/drawingml/2011/main" xmlns:a14="http://schemas.microsoft.com/office/drawing/2010/main" xmlns:m="http://schemas.openxmlformats.org/officeDocument/2006/math" xmlns="" val="1"/>
+              <ma14:wrappingTextBoxFlag xmlns="" xmlns:m="http://schemas.openxmlformats.org/officeDocument/2006/math" xmlns:a14="http://schemas.microsoft.com/office/drawing/2010/main" xmlns:ma14="http://schemas.microsoft.com/office/mac/drawingml/2011/main" val="1"/>
             </a:ext>
           </a:extLst>
         </p:spPr>
@@ -6458,7 +6332,7 @@
           </a:ln>
           <a:extLst>
             <a:ext uri="{C572A759-6A51-4108-AA02-DFA0A04FC94B}">
-              <ma14:wrappingTextBoxFlag xmlns:ma14="http://schemas.microsoft.com/office/mac/drawingml/2011/main" xmlns:a14="http://schemas.microsoft.com/office/drawing/2010/main" xmlns:m="http://schemas.openxmlformats.org/officeDocument/2006/math" xmlns="" val="1"/>
+              <ma14:wrappingTextBoxFlag xmlns="" xmlns:m="http://schemas.openxmlformats.org/officeDocument/2006/math" xmlns:a14="http://schemas.microsoft.com/office/drawing/2010/main" xmlns:ma14="http://schemas.microsoft.com/office/mac/drawingml/2011/main" val="1"/>
             </a:ext>
           </a:extLst>
         </p:spPr>
@@ -6518,7 +6392,7 @@
           </a:ln>
           <a:extLst>
             <a:ext uri="{C572A759-6A51-4108-AA02-DFA0A04FC94B}">
-              <ma14:wrappingTextBoxFlag xmlns:ma14="http://schemas.microsoft.com/office/mac/drawingml/2011/main" xmlns:a14="http://schemas.microsoft.com/office/drawing/2010/main" xmlns:m="http://schemas.openxmlformats.org/officeDocument/2006/math" xmlns="" val="1"/>
+              <ma14:wrappingTextBoxFlag xmlns="" xmlns:m="http://schemas.openxmlformats.org/officeDocument/2006/math" xmlns:a14="http://schemas.microsoft.com/office/drawing/2010/main" xmlns:ma14="http://schemas.microsoft.com/office/mac/drawingml/2011/main" val="1"/>
             </a:ext>
           </a:extLst>
         </p:spPr>

</xml_diff>